<commit_message>
docs: atualiza configs, pitch deck e documentação do codex
Co-Authored-By: Claude Opus 4.6 <noreply@anthropic.com>
</commit_message>
<xml_diff>
--- a/docs/FinApp - Pitch Deck.pptx
+++ b/docs/FinApp - Pitch Deck.pptx
@@ -5,20 +5,20 @@
     <p:sldMasterId id="2147483648" r:id="rId1"/>
   </p:sldMasterIdLst>
   <p:sldIdLst>
-    <p:sldId id="256" r:id="rId7"/>
-    <p:sldId id="257" r:id="rId8"/>
-    <p:sldId id="258" r:id="rId9"/>
-    <p:sldId id="259" r:id="rId10"/>
-    <p:sldId id="260" r:id="rId11"/>
-    <p:sldId id="261" r:id="rId12"/>
-    <p:sldId id="262" r:id="rId13"/>
-    <p:sldId id="263" r:id="rId14"/>
-    <p:sldId id="264" r:id="rId15"/>
-    <p:sldId id="265" r:id="rId16"/>
-    <p:sldId id="266" r:id="rId17"/>
-    <p:sldId id="267" r:id="rId18"/>
+    <p:sldId id="256" r:id="rId2"/>
+    <p:sldId id="257" r:id="rId3"/>
+    <p:sldId id="258" r:id="rId4"/>
+    <p:sldId id="259" r:id="rId5"/>
+    <p:sldId id="260" r:id="rId6"/>
+    <p:sldId id="261" r:id="rId7"/>
+    <p:sldId id="262" r:id="rId8"/>
+    <p:sldId id="263" r:id="rId9"/>
+    <p:sldId id="264" r:id="rId10"/>
+    <p:sldId id="265" r:id="rId11"/>
+    <p:sldId id="266" r:id="rId12"/>
+    <p:sldId id="267" r:id="rId13"/>
   </p:sldIdLst>
-  <p:sldSz cx="12191695" cy="6858000" type="screen4x3"/>
+  <p:sldSz cx="12192000" cy="6858000"/>
   <p:notesSz cx="6858000" cy="9144000"/>
   <p:defaultTextStyle>
     <a:defPPr>
@@ -115,6 +115,22 @@
       </a:defRPr>
     </a:lvl9pPr>
   </p:defaultTextStyle>
+  <p:extLst>
+    <p:ext uri="{EFAFB233-063F-42B5-8137-9DF3F51BA10A}">
+      <p15:sldGuideLst xmlns:p15="http://schemas.microsoft.com/office/powerpoint/2012/main">
+        <p15:guide id="1" orient="horz" pos="2160">
+          <p15:clr>
+            <a:srgbClr val="A4A3A4"/>
+          </p15:clr>
+        </p15:guide>
+        <p15:guide id="2" pos="2880">
+          <p15:clr>
+            <a:srgbClr val="A4A3A4"/>
+          </p15:clr>
+        </p15:guide>
+      </p15:sldGuideLst>
+    </p:ext>
+  </p:extLst>
 </p:presentation>
 </file>
 
@@ -156,10 +172,9 @@
           <a:lstStyle/>
           <a:p>
             <a:r>
-              <a:rPr lang="en-US" smtClean="0"/>
+              <a:rPr lang="en-US"/>
               <a:t>Click to edit Master title style</a:t>
             </a:r>
-            <a:endParaRPr lang="en-US"/>
           </a:p>
         </p:txBody>
       </p:sp>
@@ -275,10 +290,9 @@
           </a:lstStyle>
           <a:p>
             <a:r>
-              <a:rPr lang="en-US" smtClean="0"/>
+              <a:rPr lang="en-US"/>
               <a:t>Click to edit Master subtitle style</a:t>
             </a:r>
-            <a:endParaRPr lang="en-US"/>
           </a:p>
         </p:txBody>
       </p:sp>
@@ -299,7 +313,7 @@
           <a:p>
             <a:fld id="{5BCAD085-E8A6-8845-BD4E-CB4CCA059FC4}" type="datetimeFigureOut">
               <a:rPr lang="en-US" smtClean="0"/>
-              <a:t>1/27/13</a:t>
+              <a:t>2/27/2026</a:t>
             </a:fld>
             <a:endParaRPr lang="en-US"/>
           </a:p>
@@ -341,7 +355,7 @@
           <a:p>
             <a:fld id="{C1FF6DA9-008F-8B48-92A6-B652298478BF}" type="slidenum">
               <a:rPr lang="en-US" smtClean="0"/>
-              <a:t>‹#›</a:t>
+              <a:t>‹nº›</a:t>
             </a:fld>
             <a:endParaRPr lang="en-US"/>
           </a:p>
@@ -393,10 +407,9 @@
           <a:lstStyle/>
           <a:p>
             <a:r>
-              <a:rPr lang="en-US" smtClean="0"/>
+              <a:rPr lang="en-US"/>
               <a:t>Click to edit Master title style</a:t>
             </a:r>
-            <a:endParaRPr lang="en-US"/>
           </a:p>
         </p:txBody>
       </p:sp>
@@ -417,38 +430,37 @@
           <a:p>
             <a:pPr lvl="0"/>
             <a:r>
-              <a:rPr lang="en-US" smtClean="0"/>
+              <a:rPr lang="en-US"/>
               <a:t>Click to edit Master text styles</a:t>
             </a:r>
           </a:p>
           <a:p>
             <a:pPr lvl="1"/>
             <a:r>
-              <a:rPr lang="en-US" smtClean="0"/>
+              <a:rPr lang="en-US"/>
               <a:t>Second level</a:t>
             </a:r>
           </a:p>
           <a:p>
             <a:pPr lvl="2"/>
             <a:r>
-              <a:rPr lang="en-US" smtClean="0"/>
+              <a:rPr lang="en-US"/>
               <a:t>Third level</a:t>
             </a:r>
           </a:p>
           <a:p>
             <a:pPr lvl="3"/>
             <a:r>
-              <a:rPr lang="en-US" smtClean="0"/>
+              <a:rPr lang="en-US"/>
               <a:t>Fourth level</a:t>
             </a:r>
           </a:p>
           <a:p>
             <a:pPr lvl="4"/>
             <a:r>
-              <a:rPr lang="en-US" smtClean="0"/>
+              <a:rPr lang="en-US"/>
               <a:t>Fifth level</a:t>
             </a:r>
-            <a:endParaRPr lang="en-US"/>
           </a:p>
         </p:txBody>
       </p:sp>
@@ -469,7 +481,7 @@
           <a:p>
             <a:fld id="{5BCAD085-E8A6-8845-BD4E-CB4CCA059FC4}" type="datetimeFigureOut">
               <a:rPr lang="en-US" smtClean="0"/>
-              <a:t>1/27/13</a:t>
+              <a:t>2/27/2026</a:t>
             </a:fld>
             <a:endParaRPr lang="en-US"/>
           </a:p>
@@ -511,7 +523,7 @@
           <a:p>
             <a:fld id="{C1FF6DA9-008F-8B48-92A6-B652298478BF}" type="slidenum">
               <a:rPr lang="en-US" smtClean="0"/>
-              <a:t>‹#›</a:t>
+              <a:t>‹nº›</a:t>
             </a:fld>
             <a:endParaRPr lang="en-US"/>
           </a:p>
@@ -568,10 +580,9 @@
           <a:lstStyle/>
           <a:p>
             <a:r>
-              <a:rPr lang="en-US" smtClean="0"/>
+              <a:rPr lang="en-US"/>
               <a:t>Click to edit Master title style</a:t>
             </a:r>
-            <a:endParaRPr lang="en-US"/>
           </a:p>
         </p:txBody>
       </p:sp>
@@ -597,38 +608,37 @@
           <a:p>
             <a:pPr lvl="0"/>
             <a:r>
-              <a:rPr lang="en-US" smtClean="0"/>
+              <a:rPr lang="en-US"/>
               <a:t>Click to edit Master text styles</a:t>
             </a:r>
           </a:p>
           <a:p>
             <a:pPr lvl="1"/>
             <a:r>
-              <a:rPr lang="en-US" smtClean="0"/>
+              <a:rPr lang="en-US"/>
               <a:t>Second level</a:t>
             </a:r>
           </a:p>
           <a:p>
             <a:pPr lvl="2"/>
             <a:r>
-              <a:rPr lang="en-US" smtClean="0"/>
+              <a:rPr lang="en-US"/>
               <a:t>Third level</a:t>
             </a:r>
           </a:p>
           <a:p>
             <a:pPr lvl="3"/>
             <a:r>
-              <a:rPr lang="en-US" smtClean="0"/>
+              <a:rPr lang="en-US"/>
               <a:t>Fourth level</a:t>
             </a:r>
           </a:p>
           <a:p>
             <a:pPr lvl="4"/>
             <a:r>
-              <a:rPr lang="en-US" smtClean="0"/>
+              <a:rPr lang="en-US"/>
               <a:t>Fifth level</a:t>
             </a:r>
-            <a:endParaRPr lang="en-US"/>
           </a:p>
         </p:txBody>
       </p:sp>
@@ -649,7 +659,7 @@
           <a:p>
             <a:fld id="{5BCAD085-E8A6-8845-BD4E-CB4CCA059FC4}" type="datetimeFigureOut">
               <a:rPr lang="en-US" smtClean="0"/>
-              <a:t>1/27/13</a:t>
+              <a:t>2/27/2026</a:t>
             </a:fld>
             <a:endParaRPr lang="en-US"/>
           </a:p>
@@ -691,7 +701,7 @@
           <a:p>
             <a:fld id="{C1FF6DA9-008F-8B48-92A6-B652298478BF}" type="slidenum">
               <a:rPr lang="en-US" smtClean="0"/>
-              <a:t>‹#›</a:t>
+              <a:t>‹nº›</a:t>
             </a:fld>
             <a:endParaRPr lang="en-US"/>
           </a:p>
@@ -743,10 +753,9 @@
           <a:lstStyle/>
           <a:p>
             <a:r>
-              <a:rPr lang="en-US" smtClean="0"/>
+              <a:rPr lang="en-US"/>
               <a:t>Click to edit Master title style</a:t>
             </a:r>
-            <a:endParaRPr lang="en-US"/>
           </a:p>
         </p:txBody>
       </p:sp>
@@ -767,38 +776,37 @@
           <a:p>
             <a:pPr lvl="0"/>
             <a:r>
-              <a:rPr lang="en-US" smtClean="0"/>
+              <a:rPr lang="en-US"/>
               <a:t>Click to edit Master text styles</a:t>
             </a:r>
           </a:p>
           <a:p>
             <a:pPr lvl="1"/>
             <a:r>
-              <a:rPr lang="en-US" smtClean="0"/>
+              <a:rPr lang="en-US"/>
               <a:t>Second level</a:t>
             </a:r>
           </a:p>
           <a:p>
             <a:pPr lvl="2"/>
             <a:r>
-              <a:rPr lang="en-US" smtClean="0"/>
+              <a:rPr lang="en-US"/>
               <a:t>Third level</a:t>
             </a:r>
           </a:p>
           <a:p>
             <a:pPr lvl="3"/>
             <a:r>
-              <a:rPr lang="en-US" smtClean="0"/>
+              <a:rPr lang="en-US"/>
               <a:t>Fourth level</a:t>
             </a:r>
           </a:p>
           <a:p>
             <a:pPr lvl="4"/>
             <a:r>
-              <a:rPr lang="en-US" smtClean="0"/>
+              <a:rPr lang="en-US"/>
               <a:t>Fifth level</a:t>
             </a:r>
-            <a:endParaRPr lang="en-US"/>
           </a:p>
         </p:txBody>
       </p:sp>
@@ -819,7 +827,7 @@
           <a:p>
             <a:fld id="{5BCAD085-E8A6-8845-BD4E-CB4CCA059FC4}" type="datetimeFigureOut">
               <a:rPr lang="en-US" smtClean="0"/>
-              <a:t>1/27/13</a:t>
+              <a:t>2/27/2026</a:t>
             </a:fld>
             <a:endParaRPr lang="en-US"/>
           </a:p>
@@ -861,7 +869,7 @@
           <a:p>
             <a:fld id="{C1FF6DA9-008F-8B48-92A6-B652298478BF}" type="slidenum">
               <a:rPr lang="en-US" smtClean="0"/>
-              <a:t>‹#›</a:t>
+              <a:t>‹nº›</a:t>
             </a:fld>
             <a:endParaRPr lang="en-US"/>
           </a:p>
@@ -922,10 +930,9 @@
           </a:lstStyle>
           <a:p>
             <a:r>
-              <a:rPr lang="en-US" smtClean="0"/>
+              <a:rPr lang="en-US"/>
               <a:t>Click to edit Master title style</a:t>
             </a:r>
-            <a:endParaRPr lang="en-US"/>
           </a:p>
         </p:txBody>
       </p:sp>
@@ -1042,7 +1049,7 @@
           <a:p>
             <a:pPr lvl="0"/>
             <a:r>
-              <a:rPr lang="en-US" smtClean="0"/>
+              <a:rPr lang="en-US"/>
               <a:t>Click to edit Master text styles</a:t>
             </a:r>
           </a:p>
@@ -1065,7 +1072,7 @@
           <a:p>
             <a:fld id="{5BCAD085-E8A6-8845-BD4E-CB4CCA059FC4}" type="datetimeFigureOut">
               <a:rPr lang="en-US" smtClean="0"/>
-              <a:t>1/27/13</a:t>
+              <a:t>2/27/2026</a:t>
             </a:fld>
             <a:endParaRPr lang="en-US"/>
           </a:p>
@@ -1107,7 +1114,7 @@
           <a:p>
             <a:fld id="{C1FF6DA9-008F-8B48-92A6-B652298478BF}" type="slidenum">
               <a:rPr lang="en-US" smtClean="0"/>
-              <a:t>‹#›</a:t>
+              <a:t>‹nº›</a:t>
             </a:fld>
             <a:endParaRPr lang="en-US"/>
           </a:p>
@@ -1159,10 +1166,9 @@
           <a:lstStyle/>
           <a:p>
             <a:r>
-              <a:rPr lang="en-US" smtClean="0"/>
+              <a:rPr lang="en-US"/>
               <a:t>Click to edit Master title style</a:t>
             </a:r>
-            <a:endParaRPr lang="en-US"/>
           </a:p>
         </p:txBody>
       </p:sp>
@@ -1216,38 +1222,37 @@
           <a:p>
             <a:pPr lvl="0"/>
             <a:r>
-              <a:rPr lang="en-US" smtClean="0"/>
+              <a:rPr lang="en-US"/>
               <a:t>Click to edit Master text styles</a:t>
             </a:r>
           </a:p>
           <a:p>
             <a:pPr lvl="1"/>
             <a:r>
-              <a:rPr lang="en-US" smtClean="0"/>
+              <a:rPr lang="en-US"/>
               <a:t>Second level</a:t>
             </a:r>
           </a:p>
           <a:p>
             <a:pPr lvl="2"/>
             <a:r>
-              <a:rPr lang="en-US" smtClean="0"/>
+              <a:rPr lang="en-US"/>
               <a:t>Third level</a:t>
             </a:r>
           </a:p>
           <a:p>
             <a:pPr lvl="3"/>
             <a:r>
-              <a:rPr lang="en-US" smtClean="0"/>
+              <a:rPr lang="en-US"/>
               <a:t>Fourth level</a:t>
             </a:r>
           </a:p>
           <a:p>
             <a:pPr lvl="4"/>
             <a:r>
-              <a:rPr lang="en-US" smtClean="0"/>
+              <a:rPr lang="en-US"/>
               <a:t>Fifth level</a:t>
             </a:r>
-            <a:endParaRPr lang="en-US"/>
           </a:p>
         </p:txBody>
       </p:sp>
@@ -1301,38 +1306,37 @@
           <a:p>
             <a:pPr lvl="0"/>
             <a:r>
-              <a:rPr lang="en-US" smtClean="0"/>
+              <a:rPr lang="en-US"/>
               <a:t>Click to edit Master text styles</a:t>
             </a:r>
           </a:p>
           <a:p>
             <a:pPr lvl="1"/>
             <a:r>
-              <a:rPr lang="en-US" smtClean="0"/>
+              <a:rPr lang="en-US"/>
               <a:t>Second level</a:t>
             </a:r>
           </a:p>
           <a:p>
             <a:pPr lvl="2"/>
             <a:r>
-              <a:rPr lang="en-US" smtClean="0"/>
+              <a:rPr lang="en-US"/>
               <a:t>Third level</a:t>
             </a:r>
           </a:p>
           <a:p>
             <a:pPr lvl="3"/>
             <a:r>
-              <a:rPr lang="en-US" smtClean="0"/>
+              <a:rPr lang="en-US"/>
               <a:t>Fourth level</a:t>
             </a:r>
           </a:p>
           <a:p>
             <a:pPr lvl="4"/>
             <a:r>
-              <a:rPr lang="en-US" smtClean="0"/>
+              <a:rPr lang="en-US"/>
               <a:t>Fifth level</a:t>
             </a:r>
-            <a:endParaRPr lang="en-US"/>
           </a:p>
         </p:txBody>
       </p:sp>
@@ -1353,7 +1357,7 @@
           <a:p>
             <a:fld id="{5BCAD085-E8A6-8845-BD4E-CB4CCA059FC4}" type="datetimeFigureOut">
               <a:rPr lang="en-US" smtClean="0"/>
-              <a:t>1/27/13</a:t>
+              <a:t>2/27/2026</a:t>
             </a:fld>
             <a:endParaRPr lang="en-US"/>
           </a:p>
@@ -1395,7 +1399,7 @@
           <a:p>
             <a:fld id="{C1FF6DA9-008F-8B48-92A6-B652298478BF}" type="slidenum">
               <a:rPr lang="en-US" smtClean="0"/>
-              <a:t>‹#›</a:t>
+              <a:t>‹nº›</a:t>
             </a:fld>
             <a:endParaRPr lang="en-US"/>
           </a:p>
@@ -1451,10 +1455,9 @@
           </a:lstStyle>
           <a:p>
             <a:r>
-              <a:rPr lang="en-US" smtClean="0"/>
+              <a:rPr lang="en-US"/>
               <a:t>Click to edit Master title style</a:t>
             </a:r>
-            <a:endParaRPr lang="en-US"/>
           </a:p>
         </p:txBody>
       </p:sp>
@@ -1517,7 +1520,7 @@
           <a:p>
             <a:pPr lvl="0"/>
             <a:r>
-              <a:rPr lang="en-US" smtClean="0"/>
+              <a:rPr lang="en-US"/>
               <a:t>Click to edit Master text styles</a:t>
             </a:r>
           </a:p>
@@ -1573,38 +1576,37 @@
           <a:p>
             <a:pPr lvl="0"/>
             <a:r>
-              <a:rPr lang="en-US" smtClean="0"/>
+              <a:rPr lang="en-US"/>
               <a:t>Click to edit Master text styles</a:t>
             </a:r>
           </a:p>
           <a:p>
             <a:pPr lvl="1"/>
             <a:r>
-              <a:rPr lang="en-US" smtClean="0"/>
+              <a:rPr lang="en-US"/>
               <a:t>Second level</a:t>
             </a:r>
           </a:p>
           <a:p>
             <a:pPr lvl="2"/>
             <a:r>
-              <a:rPr lang="en-US" smtClean="0"/>
+              <a:rPr lang="en-US"/>
               <a:t>Third level</a:t>
             </a:r>
           </a:p>
           <a:p>
             <a:pPr lvl="3"/>
             <a:r>
-              <a:rPr lang="en-US" smtClean="0"/>
+              <a:rPr lang="en-US"/>
               <a:t>Fourth level</a:t>
             </a:r>
           </a:p>
           <a:p>
             <a:pPr lvl="4"/>
             <a:r>
-              <a:rPr lang="en-US" smtClean="0"/>
+              <a:rPr lang="en-US"/>
               <a:t>Fifth level</a:t>
             </a:r>
-            <a:endParaRPr lang="en-US"/>
           </a:p>
         </p:txBody>
       </p:sp>
@@ -1667,7 +1669,7 @@
           <a:p>
             <a:pPr lvl="0"/>
             <a:r>
-              <a:rPr lang="en-US" smtClean="0"/>
+              <a:rPr lang="en-US"/>
               <a:t>Click to edit Master text styles</a:t>
             </a:r>
           </a:p>
@@ -1723,38 +1725,37 @@
           <a:p>
             <a:pPr lvl="0"/>
             <a:r>
-              <a:rPr lang="en-US" smtClean="0"/>
+              <a:rPr lang="en-US"/>
               <a:t>Click to edit Master text styles</a:t>
             </a:r>
           </a:p>
           <a:p>
             <a:pPr lvl="1"/>
             <a:r>
-              <a:rPr lang="en-US" smtClean="0"/>
+              <a:rPr lang="en-US"/>
               <a:t>Second level</a:t>
             </a:r>
           </a:p>
           <a:p>
             <a:pPr lvl="2"/>
             <a:r>
-              <a:rPr lang="en-US" smtClean="0"/>
+              <a:rPr lang="en-US"/>
               <a:t>Third level</a:t>
             </a:r>
           </a:p>
           <a:p>
             <a:pPr lvl="3"/>
             <a:r>
-              <a:rPr lang="en-US" smtClean="0"/>
+              <a:rPr lang="en-US"/>
               <a:t>Fourth level</a:t>
             </a:r>
           </a:p>
           <a:p>
             <a:pPr lvl="4"/>
             <a:r>
-              <a:rPr lang="en-US" smtClean="0"/>
+              <a:rPr lang="en-US"/>
               <a:t>Fifth level</a:t>
             </a:r>
-            <a:endParaRPr lang="en-US"/>
           </a:p>
         </p:txBody>
       </p:sp>
@@ -1775,7 +1776,7 @@
           <a:p>
             <a:fld id="{5BCAD085-E8A6-8845-BD4E-CB4CCA059FC4}" type="datetimeFigureOut">
               <a:rPr lang="en-US" smtClean="0"/>
-              <a:t>1/27/13</a:t>
+              <a:t>2/27/2026</a:t>
             </a:fld>
             <a:endParaRPr lang="en-US"/>
           </a:p>
@@ -1817,7 +1818,7 @@
           <a:p>
             <a:fld id="{C1FF6DA9-008F-8B48-92A6-B652298478BF}" type="slidenum">
               <a:rPr lang="en-US" smtClean="0"/>
-              <a:t>‹#›</a:t>
+              <a:t>‹nº›</a:t>
             </a:fld>
             <a:endParaRPr lang="en-US"/>
           </a:p>
@@ -1869,10 +1870,9 @@
           <a:lstStyle/>
           <a:p>
             <a:r>
-              <a:rPr lang="en-US" smtClean="0"/>
+              <a:rPr lang="en-US"/>
               <a:t>Click to edit Master title style</a:t>
             </a:r>
-            <a:endParaRPr lang="en-US"/>
           </a:p>
         </p:txBody>
       </p:sp>
@@ -1893,7 +1893,7 @@
           <a:p>
             <a:fld id="{5BCAD085-E8A6-8845-BD4E-CB4CCA059FC4}" type="datetimeFigureOut">
               <a:rPr lang="en-US" smtClean="0"/>
-              <a:t>1/27/13</a:t>
+              <a:t>2/27/2026</a:t>
             </a:fld>
             <a:endParaRPr lang="en-US"/>
           </a:p>
@@ -1935,7 +1935,7 @@
           <a:p>
             <a:fld id="{C1FF6DA9-008F-8B48-92A6-B652298478BF}" type="slidenum">
               <a:rPr lang="en-US" smtClean="0"/>
-              <a:t>‹#›</a:t>
+              <a:t>‹nº›</a:t>
             </a:fld>
             <a:endParaRPr lang="en-US"/>
           </a:p>
@@ -1988,7 +1988,7 @@
           <a:p>
             <a:fld id="{5BCAD085-E8A6-8845-BD4E-CB4CCA059FC4}" type="datetimeFigureOut">
               <a:rPr lang="en-US" smtClean="0"/>
-              <a:t>1/27/13</a:t>
+              <a:t>2/27/2026</a:t>
             </a:fld>
             <a:endParaRPr lang="en-US"/>
           </a:p>
@@ -2030,7 +2030,7 @@
           <a:p>
             <a:fld id="{C1FF6DA9-008F-8B48-92A6-B652298478BF}" type="slidenum">
               <a:rPr lang="en-US" smtClean="0"/>
-              <a:t>‹#›</a:t>
+              <a:t>‹nº›</a:t>
             </a:fld>
             <a:endParaRPr lang="en-US"/>
           </a:p>
@@ -2091,10 +2091,9 @@
           </a:lstStyle>
           <a:p>
             <a:r>
-              <a:rPr lang="en-US" smtClean="0"/>
+              <a:rPr lang="en-US"/>
               <a:t>Click to edit Master title style</a:t>
             </a:r>
-            <a:endParaRPr lang="en-US"/>
           </a:p>
         </p:txBody>
       </p:sp>
@@ -2148,38 +2147,37 @@
           <a:p>
             <a:pPr lvl="0"/>
             <a:r>
-              <a:rPr lang="en-US" smtClean="0"/>
+              <a:rPr lang="en-US"/>
               <a:t>Click to edit Master text styles</a:t>
             </a:r>
           </a:p>
           <a:p>
             <a:pPr lvl="1"/>
             <a:r>
-              <a:rPr lang="en-US" smtClean="0"/>
+              <a:rPr lang="en-US"/>
               <a:t>Second level</a:t>
             </a:r>
           </a:p>
           <a:p>
             <a:pPr lvl="2"/>
             <a:r>
-              <a:rPr lang="en-US" smtClean="0"/>
+              <a:rPr lang="en-US"/>
               <a:t>Third level</a:t>
             </a:r>
           </a:p>
           <a:p>
             <a:pPr lvl="3"/>
             <a:r>
-              <a:rPr lang="en-US" smtClean="0"/>
+              <a:rPr lang="en-US"/>
               <a:t>Fourth level</a:t>
             </a:r>
           </a:p>
           <a:p>
             <a:pPr lvl="4"/>
             <a:r>
-              <a:rPr lang="en-US" smtClean="0"/>
+              <a:rPr lang="en-US"/>
               <a:t>Fifth level</a:t>
             </a:r>
-            <a:endParaRPr lang="en-US"/>
           </a:p>
         </p:txBody>
       </p:sp>
@@ -2242,7 +2240,7 @@
           <a:p>
             <a:pPr lvl="0"/>
             <a:r>
-              <a:rPr lang="en-US" smtClean="0"/>
+              <a:rPr lang="en-US"/>
               <a:t>Click to edit Master text styles</a:t>
             </a:r>
           </a:p>
@@ -2265,7 +2263,7 @@
           <a:p>
             <a:fld id="{5BCAD085-E8A6-8845-BD4E-CB4CCA059FC4}" type="datetimeFigureOut">
               <a:rPr lang="en-US" smtClean="0"/>
-              <a:t>1/27/13</a:t>
+              <a:t>2/27/2026</a:t>
             </a:fld>
             <a:endParaRPr lang="en-US"/>
           </a:p>
@@ -2307,7 +2305,7 @@
           <a:p>
             <a:fld id="{C1FF6DA9-008F-8B48-92A6-B652298478BF}" type="slidenum">
               <a:rPr lang="en-US" smtClean="0"/>
-              <a:t>‹#›</a:t>
+              <a:t>‹nº›</a:t>
             </a:fld>
             <a:endParaRPr lang="en-US"/>
           </a:p>
@@ -2368,10 +2366,9 @@
           </a:lstStyle>
           <a:p>
             <a:r>
-              <a:rPr lang="en-US" smtClean="0"/>
+              <a:rPr lang="en-US"/>
               <a:t>Click to edit Master title style</a:t>
             </a:r>
-            <a:endParaRPr lang="en-US"/>
           </a:p>
         </p:txBody>
       </p:sp>
@@ -2495,7 +2492,7 @@
           <a:p>
             <a:pPr lvl="0"/>
             <a:r>
-              <a:rPr lang="en-US" smtClean="0"/>
+              <a:rPr lang="en-US"/>
               <a:t>Click to edit Master text styles</a:t>
             </a:r>
           </a:p>
@@ -2518,7 +2515,7 @@
           <a:p>
             <a:fld id="{5BCAD085-E8A6-8845-BD4E-CB4CCA059FC4}" type="datetimeFigureOut">
               <a:rPr lang="en-US" smtClean="0"/>
-              <a:t>1/27/13</a:t>
+              <a:t>2/27/2026</a:t>
             </a:fld>
             <a:endParaRPr lang="en-US"/>
           </a:p>
@@ -2560,7 +2557,7 @@
           <a:p>
             <a:fld id="{C1FF6DA9-008F-8B48-92A6-B652298478BF}" type="slidenum">
               <a:rPr lang="en-US" smtClean="0"/>
-              <a:t>‹#›</a:t>
+              <a:t>‹nº›</a:t>
             </a:fld>
             <a:endParaRPr lang="en-US"/>
           </a:p>
@@ -2627,10 +2624,9 @@
           <a:lstStyle/>
           <a:p>
             <a:r>
-              <a:rPr lang="en-US" smtClean="0"/>
+              <a:rPr lang="en-US"/>
               <a:t>Click to edit Master title style</a:t>
             </a:r>
-            <a:endParaRPr lang="en-US"/>
           </a:p>
         </p:txBody>
       </p:sp>
@@ -2661,38 +2657,37 @@
           <a:p>
             <a:pPr lvl="0"/>
             <a:r>
-              <a:rPr lang="en-US" smtClean="0"/>
+              <a:rPr lang="en-US"/>
               <a:t>Click to edit Master text styles</a:t>
             </a:r>
           </a:p>
           <a:p>
             <a:pPr lvl="1"/>
             <a:r>
-              <a:rPr lang="en-US" smtClean="0"/>
+              <a:rPr lang="en-US"/>
               <a:t>Second level</a:t>
             </a:r>
           </a:p>
           <a:p>
             <a:pPr lvl="2"/>
             <a:r>
-              <a:rPr lang="en-US" smtClean="0"/>
+              <a:rPr lang="en-US"/>
               <a:t>Third level</a:t>
             </a:r>
           </a:p>
           <a:p>
             <a:pPr lvl="3"/>
             <a:r>
-              <a:rPr lang="en-US" smtClean="0"/>
+              <a:rPr lang="en-US"/>
               <a:t>Fourth level</a:t>
             </a:r>
           </a:p>
           <a:p>
             <a:pPr lvl="4"/>
             <a:r>
-              <a:rPr lang="en-US" smtClean="0"/>
+              <a:rPr lang="en-US"/>
               <a:t>Fifth level</a:t>
             </a:r>
-            <a:endParaRPr lang="en-US"/>
           </a:p>
         </p:txBody>
       </p:sp>
@@ -2731,7 +2726,7 @@
           <a:p>
             <a:fld id="{5BCAD085-E8A6-8845-BD4E-CB4CCA059FC4}" type="datetimeFigureOut">
               <a:rPr lang="en-US" smtClean="0"/>
-              <a:t>1/27/13</a:t>
+              <a:t>2/27/2026</a:t>
             </a:fld>
             <a:endParaRPr lang="en-US"/>
           </a:p>
@@ -2809,7 +2804,7 @@
           <a:p>
             <a:fld id="{C1FF6DA9-008F-8B48-92A6-B652298478BF}" type="slidenum">
               <a:rPr lang="en-US" smtClean="0"/>
-              <a:t>‹#›</a:t>
+              <a:t>‹nº›</a:t>
             </a:fld>
             <a:endParaRPr lang="en-US"/>
           </a:p>
@@ -3090,7 +3085,7 @@
 </file>
 
 <file path=ppt/slides/slide1.xml><?xml version="1.0" encoding="utf-8"?>
-<p:sld xmlns:a="http://schemas.openxmlformats.org/drawingml/2006/main" xmlns:p="http://schemas.openxmlformats.org/presentationml/2006/main" xmlns:r="http://schemas.openxmlformats.org/officeDocument/2006/relationships">
+<p:sld xmlns:a="http://schemas.openxmlformats.org/drawingml/2006/main" xmlns:r="http://schemas.openxmlformats.org/officeDocument/2006/relationships" xmlns:p="http://schemas.openxmlformats.org/presentationml/2006/main">
   <p:cSld>
     <p:bg>
       <p:bgPr>
@@ -3106,7 +3101,14 @@
         <p:cNvGrpSpPr/>
         <p:nvPr/>
       </p:nvGrpSpPr>
-      <p:grpSpPr/>
+      <p:grpSpPr>
+        <a:xfrm>
+          <a:off x="0" y="0"/>
+          <a:ext cx="0" cy="0"/>
+          <a:chOff x="0" y="0"/>
+          <a:chExt cx="0" cy="0"/>
+        </a:xfrm>
+      </p:grpSpPr>
       <p:sp>
         <p:nvSpPr>
           <p:cNvPr id="2" name="Rectangle 1"/>
@@ -3147,6 +3149,7 @@
           <a:lstStyle/>
           <a:p>
             <a:pPr algn="ctr"/>
+            <a:endParaRPr/>
           </a:p>
         </p:txBody>
       </p:sp>
@@ -3190,6 +3193,7 @@
           <a:lstStyle/>
           <a:p>
             <a:pPr algn="ctr"/>
+            <a:endParaRPr/>
           </a:p>
         </p:txBody>
       </p:sp>
@@ -3233,6 +3237,7 @@
           <a:lstStyle/>
           <a:p>
             <a:pPr algn="ctr"/>
+            <a:endParaRPr/>
           </a:p>
         </p:txBody>
       </p:sp>
@@ -3378,6 +3383,7 @@
           <a:lstStyle/>
           <a:p>
             <a:pPr algn="ctr"/>
+            <a:endParaRPr/>
           </a:p>
         </p:txBody>
       </p:sp>
@@ -3424,7 +3430,7 @@
 </file>
 
 <file path=ppt/slides/slide10.xml><?xml version="1.0" encoding="utf-8"?>
-<p:sld xmlns:a="http://schemas.openxmlformats.org/drawingml/2006/main" xmlns:p="http://schemas.openxmlformats.org/presentationml/2006/main" xmlns:r="http://schemas.openxmlformats.org/officeDocument/2006/relationships">
+<p:sld xmlns:a="http://schemas.openxmlformats.org/drawingml/2006/main" xmlns:r="http://schemas.openxmlformats.org/officeDocument/2006/relationships" xmlns:p="http://schemas.openxmlformats.org/presentationml/2006/main">
   <p:cSld>
     <p:bg>
       <p:bgPr>
@@ -3440,7 +3446,14 @@
         <p:cNvGrpSpPr/>
         <p:nvPr/>
       </p:nvGrpSpPr>
-      <p:grpSpPr/>
+      <p:grpSpPr>
+        <a:xfrm>
+          <a:off x="0" y="0"/>
+          <a:ext cx="0" cy="0"/>
+          <a:chOff x="0" y="0"/>
+          <a:chExt cx="0" cy="0"/>
+        </a:xfrm>
+      </p:grpSpPr>
       <p:sp>
         <p:nvSpPr>
           <p:cNvPr id="2" name="TextBox 1"/>
@@ -3549,6 +3562,7 @@
           <a:lstStyle/>
           <a:p>
             <a:pPr algn="ctr"/>
+            <a:endParaRPr/>
           </a:p>
         </p:txBody>
       </p:sp>
@@ -3667,6 +3681,7 @@
           <a:lstStyle/>
           <a:p>
             <a:pPr algn="ctr"/>
+            <a:endParaRPr/>
           </a:p>
         </p:txBody>
       </p:sp>
@@ -3785,6 +3800,7 @@
           <a:lstStyle/>
           <a:p>
             <a:pPr algn="ctr"/>
+            <a:endParaRPr/>
           </a:p>
         </p:txBody>
       </p:sp>
@@ -3903,6 +3919,7 @@
           <a:lstStyle/>
           <a:p>
             <a:pPr algn="ctr"/>
+            <a:endParaRPr/>
           </a:p>
         </p:txBody>
       </p:sp>
@@ -4171,7 +4188,7 @@
 </file>
 
 <file path=ppt/slides/slide11.xml><?xml version="1.0" encoding="utf-8"?>
-<p:sld xmlns:a="http://schemas.openxmlformats.org/drawingml/2006/main" xmlns:p="http://schemas.openxmlformats.org/presentationml/2006/main" xmlns:r="http://schemas.openxmlformats.org/officeDocument/2006/relationships">
+<p:sld xmlns:a="http://schemas.openxmlformats.org/drawingml/2006/main" xmlns:r="http://schemas.openxmlformats.org/officeDocument/2006/relationships" xmlns:p="http://schemas.openxmlformats.org/presentationml/2006/main">
   <p:cSld>
     <p:bg>
       <p:bgPr>
@@ -4187,7 +4204,14 @@
         <p:cNvGrpSpPr/>
         <p:nvPr/>
       </p:nvGrpSpPr>
-      <p:grpSpPr/>
+      <p:grpSpPr>
+        <a:xfrm>
+          <a:off x="0" y="0"/>
+          <a:ext cx="0" cy="0"/>
+          <a:chOff x="0" y="0"/>
+          <a:chExt cx="0" cy="0"/>
+        </a:xfrm>
+      </p:grpSpPr>
       <p:sp>
         <p:nvSpPr>
           <p:cNvPr id="2" name="TextBox 1"/>
@@ -4296,6 +4320,7 @@
           <a:lstStyle/>
           <a:p>
             <a:pPr algn="ctr"/>
+            <a:endParaRPr/>
           </a:p>
         </p:txBody>
       </p:sp>
@@ -4373,6 +4398,7 @@
           <a:lstStyle/>
           <a:p>
             <a:pPr algn="ctr"/>
+            <a:endParaRPr/>
           </a:p>
         </p:txBody>
       </p:sp>
@@ -4470,6 +4496,7 @@
           <a:lstStyle/>
           <a:p>
             <a:pPr algn="ctr"/>
+            <a:endParaRPr/>
           </a:p>
         </p:txBody>
       </p:sp>
@@ -4547,6 +4574,7 @@
           <a:lstStyle/>
           <a:p>
             <a:pPr algn="ctr"/>
+            <a:endParaRPr/>
           </a:p>
         </p:txBody>
       </p:sp>
@@ -4643,6 +4671,7 @@
           <a:lstStyle/>
           <a:p>
             <a:pPr algn="ctr"/>
+            <a:endParaRPr/>
           </a:p>
         </p:txBody>
       </p:sp>
@@ -4720,6 +4749,7 @@
           <a:lstStyle/>
           <a:p>
             <a:pPr algn="ctr"/>
+            <a:endParaRPr/>
           </a:p>
         </p:txBody>
       </p:sp>
@@ -4782,7 +4812,7 @@
 </file>
 
 <file path=ppt/slides/slide12.xml><?xml version="1.0" encoding="utf-8"?>
-<p:sld xmlns:a="http://schemas.openxmlformats.org/drawingml/2006/main" xmlns:p="http://schemas.openxmlformats.org/presentationml/2006/main" xmlns:r="http://schemas.openxmlformats.org/officeDocument/2006/relationships">
+<p:sld xmlns:a="http://schemas.openxmlformats.org/drawingml/2006/main" xmlns:r="http://schemas.openxmlformats.org/officeDocument/2006/relationships" xmlns:p="http://schemas.openxmlformats.org/presentationml/2006/main">
   <p:cSld>
     <p:bg>
       <p:bgPr>
@@ -4798,7 +4828,14 @@
         <p:cNvGrpSpPr/>
         <p:nvPr/>
       </p:nvGrpSpPr>
-      <p:grpSpPr/>
+      <p:grpSpPr>
+        <a:xfrm>
+          <a:off x="0" y="0"/>
+          <a:ext cx="0" cy="0"/>
+          <a:chOff x="0" y="0"/>
+          <a:chExt cx="0" cy="0"/>
+        </a:xfrm>
+      </p:grpSpPr>
       <p:sp>
         <p:nvSpPr>
           <p:cNvPr id="2" name="Rectangle 1"/>
@@ -4839,6 +4876,7 @@
           <a:lstStyle/>
           <a:p>
             <a:pPr algn="ctr"/>
+            <a:endParaRPr/>
           </a:p>
         </p:txBody>
       </p:sp>
@@ -4882,6 +4920,7 @@
           <a:lstStyle/>
           <a:p>
             <a:pPr algn="ctr"/>
+            <a:endParaRPr/>
           </a:p>
         </p:txBody>
       </p:sp>
@@ -5000,6 +5039,7 @@
           <a:lstStyle/>
           <a:p>
             <a:pPr algn="ctr"/>
+            <a:endParaRPr/>
           </a:p>
         </p:txBody>
       </p:sp>
@@ -5077,6 +5117,7 @@
           <a:lstStyle/>
           <a:p>
             <a:pPr algn="ctr"/>
+            <a:endParaRPr/>
           </a:p>
         </p:txBody>
       </p:sp>
@@ -5123,7 +5164,7 @@
 </file>
 
 <file path=ppt/slides/slide2.xml><?xml version="1.0" encoding="utf-8"?>
-<p:sld xmlns:a="http://schemas.openxmlformats.org/drawingml/2006/main" xmlns:p="http://schemas.openxmlformats.org/presentationml/2006/main" xmlns:r="http://schemas.openxmlformats.org/officeDocument/2006/relationships">
+<p:sld xmlns:a="http://schemas.openxmlformats.org/drawingml/2006/main" xmlns:r="http://schemas.openxmlformats.org/officeDocument/2006/relationships" xmlns:p="http://schemas.openxmlformats.org/presentationml/2006/main">
   <p:cSld>
     <p:bg>
       <p:bgPr>
@@ -5139,7 +5180,14 @@
         <p:cNvGrpSpPr/>
         <p:nvPr/>
       </p:nvGrpSpPr>
-      <p:grpSpPr/>
+      <p:grpSpPr>
+        <a:xfrm>
+          <a:off x="0" y="0"/>
+          <a:ext cx="0" cy="0"/>
+          <a:chOff x="0" y="0"/>
+          <a:chExt cx="0" cy="0"/>
+        </a:xfrm>
+      </p:grpSpPr>
       <p:sp>
         <p:nvSpPr>
           <p:cNvPr id="2" name="TextBox 1"/>
@@ -5284,6 +5332,7 @@
           <a:lstStyle/>
           <a:p>
             <a:pPr algn="ctr"/>
+            <a:endParaRPr/>
           </a:p>
         </p:txBody>
       </p:sp>
@@ -5327,6 +5376,7 @@
           <a:lstStyle/>
           <a:p>
             <a:pPr algn="ctr"/>
+            <a:endParaRPr/>
           </a:p>
         </p:txBody>
       </p:sp>
@@ -5451,6 +5501,7 @@
           <a:lstStyle/>
           <a:p>
             <a:pPr algn="ctr"/>
+            <a:endParaRPr/>
           </a:p>
         </p:txBody>
       </p:sp>
@@ -5494,6 +5545,7 @@
           <a:lstStyle/>
           <a:p>
             <a:pPr algn="ctr"/>
+            <a:endParaRPr/>
           </a:p>
         </p:txBody>
       </p:sp>
@@ -5618,6 +5670,7 @@
           <a:lstStyle/>
           <a:p>
             <a:pPr algn="ctr"/>
+            <a:endParaRPr/>
           </a:p>
         </p:txBody>
       </p:sp>
@@ -5661,6 +5714,7 @@
           <a:lstStyle/>
           <a:p>
             <a:pPr algn="ctr"/>
+            <a:endParaRPr/>
           </a:p>
         </p:txBody>
       </p:sp>
@@ -5786,7 +5840,7 @@
 </file>
 
 <file path=ppt/slides/slide3.xml><?xml version="1.0" encoding="utf-8"?>
-<p:sld xmlns:a="http://schemas.openxmlformats.org/drawingml/2006/main" xmlns:p="http://schemas.openxmlformats.org/presentationml/2006/main" xmlns:r="http://schemas.openxmlformats.org/officeDocument/2006/relationships">
+<p:sld xmlns:a="http://schemas.openxmlformats.org/drawingml/2006/main" xmlns:r="http://schemas.openxmlformats.org/officeDocument/2006/relationships" xmlns:p="http://schemas.openxmlformats.org/presentationml/2006/main">
   <p:cSld>
     <p:bg>
       <p:bgPr>
@@ -5802,7 +5856,14 @@
         <p:cNvGrpSpPr/>
         <p:nvPr/>
       </p:nvGrpSpPr>
-      <p:grpSpPr/>
+      <p:grpSpPr>
+        <a:xfrm>
+          <a:off x="0" y="0"/>
+          <a:ext cx="0" cy="0"/>
+          <a:chOff x="0" y="0"/>
+          <a:chExt cx="0" cy="0"/>
+        </a:xfrm>
+      </p:grpSpPr>
       <p:sp>
         <p:nvSpPr>
           <p:cNvPr id="2" name="TextBox 1"/>
@@ -5913,6 +5974,7 @@
           <a:lstStyle/>
           <a:p>
             <a:pPr algn="ctr"/>
+            <a:endParaRPr/>
           </a:p>
         </p:txBody>
       </p:sp>
@@ -6063,6 +6125,7 @@
           <a:lstStyle/>
           <a:p>
             <a:pPr algn="ctr"/>
+            <a:endParaRPr/>
           </a:p>
         </p:txBody>
       </p:sp>
@@ -6213,6 +6276,7 @@
           <a:lstStyle/>
           <a:p>
             <a:pPr algn="ctr"/>
+            <a:endParaRPr/>
           </a:p>
         </p:txBody>
       </p:sp>
@@ -6363,6 +6427,7 @@
           <a:lstStyle/>
           <a:p>
             <a:pPr algn="ctr"/>
+            <a:endParaRPr/>
           </a:p>
         </p:txBody>
       </p:sp>
@@ -6514,7 +6579,7 @@
 </file>
 
 <file path=ppt/slides/slide4.xml><?xml version="1.0" encoding="utf-8"?>
-<p:sld xmlns:a="http://schemas.openxmlformats.org/drawingml/2006/main" xmlns:p="http://schemas.openxmlformats.org/presentationml/2006/main" xmlns:r="http://schemas.openxmlformats.org/officeDocument/2006/relationships">
+<p:sld xmlns:a="http://schemas.openxmlformats.org/drawingml/2006/main" xmlns:r="http://schemas.openxmlformats.org/officeDocument/2006/relationships" xmlns:p="http://schemas.openxmlformats.org/presentationml/2006/main">
   <p:cSld>
     <p:bg>
       <p:bgPr>
@@ -6530,7 +6595,14 @@
         <p:cNvGrpSpPr/>
         <p:nvPr/>
       </p:nvGrpSpPr>
-      <p:grpSpPr/>
+      <p:grpSpPr>
+        <a:xfrm>
+          <a:off x="0" y="0"/>
+          <a:ext cx="0" cy="0"/>
+          <a:chOff x="0" y="0"/>
+          <a:chExt cx="0" cy="0"/>
+        </a:xfrm>
+      </p:grpSpPr>
       <p:sp>
         <p:nvSpPr>
           <p:cNvPr id="2" name="TextBox 1"/>
@@ -6607,7 +6679,7 @@
         </p:nvSpPr>
         <p:spPr>
           <a:xfrm>
-            <a:off x="731520" y="1417320"/>
+            <a:off x="731520" y="1817924"/>
             <a:ext cx="9144000" cy="457200"/>
           </a:xfrm>
           <a:prstGeom prst="rect">
@@ -6628,7 +6700,84 @@
               </a:defRPr>
             </a:pPr>
             <a:r>
-              <a:t>Cada uma ataca um pedaco — nenhuma oferece a visao integrada que o usuario precisa.</a:t>
+              <a:rPr dirty="0" err="1"/>
+              <a:t>Cada</a:t>
+            </a:r>
+            <a:r>
+              <a:rPr dirty="0"/>
+              <a:t> </a:t>
+            </a:r>
+            <a:r>
+              <a:rPr dirty="0" err="1"/>
+              <a:t>uma</a:t>
+            </a:r>
+            <a:r>
+              <a:rPr dirty="0"/>
+              <a:t> </a:t>
+            </a:r>
+            <a:r>
+              <a:rPr dirty="0" err="1"/>
+              <a:t>ataca</a:t>
+            </a:r>
+            <a:r>
+              <a:rPr dirty="0"/>
+              <a:t> um </a:t>
+            </a:r>
+            <a:r>
+              <a:rPr dirty="0" err="1"/>
+              <a:t>pedaco</a:t>
+            </a:r>
+            <a:r>
+              <a:rPr dirty="0"/>
+              <a:t> — </a:t>
+            </a:r>
+            <a:r>
+              <a:rPr dirty="0" err="1"/>
+              <a:t>nenhuma</a:t>
+            </a:r>
+            <a:r>
+              <a:rPr dirty="0"/>
+              <a:t> </a:t>
+            </a:r>
+            <a:r>
+              <a:rPr dirty="0" err="1"/>
+              <a:t>oferece</a:t>
+            </a:r>
+            <a:r>
+              <a:rPr dirty="0"/>
+              <a:t> a </a:t>
+            </a:r>
+            <a:r>
+              <a:rPr dirty="0" err="1"/>
+              <a:t>visao</a:t>
+            </a:r>
+            <a:r>
+              <a:rPr dirty="0"/>
+              <a:t> </a:t>
+            </a:r>
+            <a:r>
+              <a:rPr dirty="0" err="1"/>
+              <a:t>integrada</a:t>
+            </a:r>
+            <a:r>
+              <a:rPr dirty="0"/>
+              <a:t> que o </a:t>
+            </a:r>
+            <a:r>
+              <a:rPr dirty="0" err="1"/>
+              <a:t>usuario</a:t>
+            </a:r>
+            <a:r>
+              <a:rPr dirty="0"/>
+              <a:t> </a:t>
+            </a:r>
+            <a:r>
+              <a:rPr dirty="0" err="1"/>
+              <a:t>precisa</a:t>
+            </a:r>
+            <a:r>
+              <a:rPr dirty="0"/>
+              <a:t>.</a:t>
             </a:r>
           </a:p>
         </p:txBody>
@@ -6641,7 +6790,7 @@
         </p:nvSpPr>
         <p:spPr>
           <a:xfrm>
-            <a:off x="731520" y="2194560"/>
+            <a:off x="731520" y="3030585"/>
             <a:ext cx="2514600" cy="2926080"/>
           </a:xfrm>
           <a:prstGeom prst="roundRect">
@@ -6675,6 +6824,7 @@
           <a:lstStyle/>
           <a:p>
             <a:pPr algn="ctr"/>
+            <a:endParaRPr/>
           </a:p>
         </p:txBody>
       </p:sp>
@@ -6686,7 +6836,7 @@
         </p:nvSpPr>
         <p:spPr>
           <a:xfrm>
-            <a:off x="960120" y="2423160"/>
+            <a:off x="960120" y="3259185"/>
             <a:ext cx="2057400" cy="640080"/>
           </a:xfrm>
           <a:prstGeom prst="rect">
@@ -6720,7 +6870,7 @@
         </p:nvSpPr>
         <p:spPr>
           <a:xfrm>
-            <a:off x="960120" y="3108960"/>
+            <a:off x="960120" y="3944985"/>
             <a:ext cx="2057400" cy="1280160"/>
           </a:xfrm>
           <a:prstGeom prst="rect">
@@ -6765,7 +6915,7 @@
         </p:nvSpPr>
         <p:spPr>
           <a:xfrm>
-            <a:off x="960120" y="4572000"/>
+            <a:off x="960120" y="5408025"/>
             <a:ext cx="2057400" cy="365760"/>
           </a:xfrm>
           <a:prstGeom prst="rect">
@@ -6799,7 +6949,7 @@
         </p:nvSpPr>
         <p:spPr>
           <a:xfrm>
-            <a:off x="3566160" y="2194560"/>
+            <a:off x="3566160" y="3030585"/>
             <a:ext cx="2514600" cy="2926080"/>
           </a:xfrm>
           <a:prstGeom prst="roundRect">
@@ -6833,6 +6983,7 @@
           <a:lstStyle/>
           <a:p>
             <a:pPr algn="ctr"/>
+            <a:endParaRPr/>
           </a:p>
         </p:txBody>
       </p:sp>
@@ -6844,7 +6995,7 @@
         </p:nvSpPr>
         <p:spPr>
           <a:xfrm>
-            <a:off x="3794760" y="2423160"/>
+            <a:off x="3794760" y="3259185"/>
             <a:ext cx="2057400" cy="640080"/>
           </a:xfrm>
           <a:prstGeom prst="rect">
@@ -6878,7 +7029,7 @@
         </p:nvSpPr>
         <p:spPr>
           <a:xfrm>
-            <a:off x="3794760" y="3108960"/>
+            <a:off x="3794760" y="3944985"/>
             <a:ext cx="2057400" cy="1280160"/>
           </a:xfrm>
           <a:prstGeom prst="rect">
@@ -6923,7 +7074,7 @@
         </p:nvSpPr>
         <p:spPr>
           <a:xfrm>
-            <a:off x="3794760" y="4572000"/>
+            <a:off x="3794760" y="5408025"/>
             <a:ext cx="2057400" cy="365760"/>
           </a:xfrm>
           <a:prstGeom prst="rect">
@@ -6957,7 +7108,7 @@
         </p:nvSpPr>
         <p:spPr>
           <a:xfrm>
-            <a:off x="6400800" y="2194560"/>
+            <a:off x="6400800" y="3030585"/>
             <a:ext cx="2514600" cy="2926080"/>
           </a:xfrm>
           <a:prstGeom prst="roundRect">
@@ -6991,6 +7142,7 @@
           <a:lstStyle/>
           <a:p>
             <a:pPr algn="ctr"/>
+            <a:endParaRPr/>
           </a:p>
         </p:txBody>
       </p:sp>
@@ -7002,7 +7154,7 @@
         </p:nvSpPr>
         <p:spPr>
           <a:xfrm>
-            <a:off x="6629400" y="2423160"/>
+            <a:off x="6629400" y="3259185"/>
             <a:ext cx="2057400" cy="640080"/>
           </a:xfrm>
           <a:prstGeom prst="rect">
@@ -7036,7 +7188,7 @@
         </p:nvSpPr>
         <p:spPr>
           <a:xfrm>
-            <a:off x="6629400" y="3108960"/>
+            <a:off x="6629400" y="3944985"/>
             <a:ext cx="2057400" cy="1280160"/>
           </a:xfrm>
           <a:prstGeom prst="rect">
@@ -7081,7 +7233,7 @@
         </p:nvSpPr>
         <p:spPr>
           <a:xfrm>
-            <a:off x="6629400" y="4572000"/>
+            <a:off x="6629400" y="5408025"/>
             <a:ext cx="2057400" cy="365760"/>
           </a:xfrm>
           <a:prstGeom prst="rect">
@@ -7115,7 +7267,7 @@
         </p:nvSpPr>
         <p:spPr>
           <a:xfrm>
-            <a:off x="9235440" y="2194560"/>
+            <a:off x="9235440" y="3030585"/>
             <a:ext cx="2514600" cy="2926080"/>
           </a:xfrm>
           <a:prstGeom prst="roundRect">
@@ -7149,6 +7301,7 @@
           <a:lstStyle/>
           <a:p>
             <a:pPr algn="ctr"/>
+            <a:endParaRPr/>
           </a:p>
         </p:txBody>
       </p:sp>
@@ -7160,7 +7313,7 @@
         </p:nvSpPr>
         <p:spPr>
           <a:xfrm>
-            <a:off x="9464040" y="2423160"/>
+            <a:off x="9464040" y="3259185"/>
             <a:ext cx="2057400" cy="640080"/>
           </a:xfrm>
           <a:prstGeom prst="rect">
@@ -7198,7 +7351,7 @@
         </p:nvSpPr>
         <p:spPr>
           <a:xfrm>
-            <a:off x="9464040" y="3108960"/>
+            <a:off x="9464040" y="3944985"/>
             <a:ext cx="2057400" cy="1280160"/>
           </a:xfrm>
           <a:prstGeom prst="rect">
@@ -7243,7 +7396,7 @@
         </p:nvSpPr>
         <p:spPr>
           <a:xfrm>
-            <a:off x="9464040" y="4572000"/>
+            <a:off x="9464040" y="5408025"/>
             <a:ext cx="2057400" cy="365760"/>
           </a:xfrm>
           <a:prstGeom prst="rect">
@@ -7278,7 +7431,7 @@
 </file>
 
 <file path=ppt/slides/slide5.xml><?xml version="1.0" encoding="utf-8"?>
-<p:sld xmlns:a="http://schemas.openxmlformats.org/drawingml/2006/main" xmlns:p="http://schemas.openxmlformats.org/presentationml/2006/main" xmlns:r="http://schemas.openxmlformats.org/officeDocument/2006/relationships">
+<p:sld xmlns:a="http://schemas.openxmlformats.org/drawingml/2006/main" xmlns:r="http://schemas.openxmlformats.org/officeDocument/2006/relationships" xmlns:p="http://schemas.openxmlformats.org/presentationml/2006/main">
   <p:cSld>
     <p:bg>
       <p:bgPr>
@@ -7294,7 +7447,14 @@
         <p:cNvGrpSpPr/>
         <p:nvPr/>
       </p:nvGrpSpPr>
-      <p:grpSpPr/>
+      <p:grpSpPr>
+        <a:xfrm>
+          <a:off x="0" y="0"/>
+          <a:ext cx="0" cy="0"/>
+          <a:chOff x="0" y="0"/>
+          <a:chExt cx="0" cy="0"/>
+        </a:xfrm>
+      </p:grpSpPr>
       <p:sp>
         <p:nvSpPr>
           <p:cNvPr id="2" name="TextBox 1"/>
@@ -7337,7 +7497,7 @@
         </p:nvSpPr>
         <p:spPr>
           <a:xfrm>
-            <a:off x="731520" y="685800"/>
+            <a:off x="731520" y="633546"/>
             <a:ext cx="9144000" cy="548640"/>
           </a:xfrm>
           <a:prstGeom prst="rect">
@@ -7358,7 +7518,36 @@
               </a:defRPr>
             </a:pPr>
             <a:r>
-              <a:t>FinApp vs. concorrentes: funcionalidade por funcionalidade.</a:t>
+              <a:rPr dirty="0" err="1"/>
+              <a:t>FinApp</a:t>
+            </a:r>
+            <a:r>
+              <a:rPr dirty="0"/>
+              <a:t> vs. </a:t>
+            </a:r>
+            <a:r>
+              <a:rPr dirty="0" err="1"/>
+              <a:t>concorrentes</a:t>
+            </a:r>
+            <a:r>
+              <a:rPr dirty="0"/>
+              <a:t>: </a:t>
+            </a:r>
+            <a:r>
+              <a:rPr dirty="0" err="1"/>
+              <a:t>funcionalidade</a:t>
+            </a:r>
+            <a:r>
+              <a:rPr dirty="0"/>
+              <a:t> por </a:t>
+            </a:r>
+            <a:r>
+              <a:rPr dirty="0" err="1"/>
+              <a:t>funcionalidade</a:t>
+            </a:r>
+            <a:r>
+              <a:rPr dirty="0"/>
+              <a:t>.</a:t>
             </a:r>
           </a:p>
         </p:txBody>
@@ -7403,6 +7592,7 @@
           <a:lstStyle/>
           <a:p>
             <a:pPr algn="ctr"/>
+            <a:endParaRPr/>
           </a:p>
         </p:txBody>
       </p:sp>
@@ -7548,6 +7738,7 @@
           <a:lstStyle/>
           <a:p>
             <a:pPr algn="ctr"/>
+            <a:endParaRPr/>
           </a:p>
         </p:txBody>
       </p:sp>
@@ -7591,6 +7782,7 @@
           <a:lstStyle/>
           <a:p>
             <a:pPr algn="ctr"/>
+            <a:endParaRPr/>
           </a:p>
         </p:txBody>
       </p:sp>
@@ -7736,6 +7928,7 @@
           <a:lstStyle/>
           <a:p>
             <a:pPr algn="ctr"/>
+            <a:endParaRPr/>
           </a:p>
         </p:txBody>
       </p:sp>
@@ -7779,6 +7972,7 @@
           <a:lstStyle/>
           <a:p>
             <a:pPr algn="ctr"/>
+            <a:endParaRPr/>
           </a:p>
         </p:txBody>
       </p:sp>
@@ -7924,6 +8118,7 @@
           <a:lstStyle/>
           <a:p>
             <a:pPr algn="ctr"/>
+            <a:endParaRPr/>
           </a:p>
         </p:txBody>
       </p:sp>
@@ -7967,6 +8162,7 @@
           <a:lstStyle/>
           <a:p>
             <a:pPr algn="ctr"/>
+            <a:endParaRPr/>
           </a:p>
         </p:txBody>
       </p:sp>
@@ -8112,6 +8308,7 @@
           <a:lstStyle/>
           <a:p>
             <a:pPr algn="ctr"/>
+            <a:endParaRPr/>
           </a:p>
         </p:txBody>
       </p:sp>
@@ -8155,6 +8352,7 @@
           <a:lstStyle/>
           <a:p>
             <a:pPr algn="ctr"/>
+            <a:endParaRPr/>
           </a:p>
         </p:txBody>
       </p:sp>
@@ -8300,6 +8498,7 @@
           <a:lstStyle/>
           <a:p>
             <a:pPr algn="ctr"/>
+            <a:endParaRPr/>
           </a:p>
         </p:txBody>
       </p:sp>
@@ -8343,6 +8542,7 @@
           <a:lstStyle/>
           <a:p>
             <a:pPr algn="ctr"/>
+            <a:endParaRPr/>
           </a:p>
         </p:txBody>
       </p:sp>
@@ -8488,6 +8688,7 @@
           <a:lstStyle/>
           <a:p>
             <a:pPr algn="ctr"/>
+            <a:endParaRPr/>
           </a:p>
         </p:txBody>
       </p:sp>
@@ -8531,6 +8732,7 @@
           <a:lstStyle/>
           <a:p>
             <a:pPr algn="ctr"/>
+            <a:endParaRPr/>
           </a:p>
         </p:txBody>
       </p:sp>
@@ -8676,6 +8878,7 @@
           <a:lstStyle/>
           <a:p>
             <a:pPr algn="ctr"/>
+            <a:endParaRPr/>
           </a:p>
         </p:txBody>
       </p:sp>
@@ -8719,6 +8922,7 @@
           <a:lstStyle/>
           <a:p>
             <a:pPr algn="ctr"/>
+            <a:endParaRPr/>
           </a:p>
         </p:txBody>
       </p:sp>
@@ -8864,6 +9068,7 @@
           <a:lstStyle/>
           <a:p>
             <a:pPr algn="ctr"/>
+            <a:endParaRPr/>
           </a:p>
         </p:txBody>
       </p:sp>
@@ -8907,6 +9112,7 @@
           <a:lstStyle/>
           <a:p>
             <a:pPr algn="ctr"/>
+            <a:endParaRPr/>
           </a:p>
         </p:txBody>
       </p:sp>
@@ -9052,6 +9258,7 @@
           <a:lstStyle/>
           <a:p>
             <a:pPr algn="ctr"/>
+            <a:endParaRPr/>
           </a:p>
         </p:txBody>
       </p:sp>
@@ -9095,6 +9302,7 @@
           <a:lstStyle/>
           <a:p>
             <a:pPr algn="ctr"/>
+            <a:endParaRPr/>
           </a:p>
         </p:txBody>
       </p:sp>
@@ -9240,6 +9448,7 @@
           <a:lstStyle/>
           <a:p>
             <a:pPr algn="ctr"/>
+            <a:endParaRPr/>
           </a:p>
         </p:txBody>
       </p:sp>
@@ -9283,6 +9492,7 @@
           <a:lstStyle/>
           <a:p>
             <a:pPr algn="ctr"/>
+            <a:endParaRPr/>
           </a:p>
         </p:txBody>
       </p:sp>
@@ -9428,6 +9638,7 @@
           <a:lstStyle/>
           <a:p>
             <a:pPr algn="ctr"/>
+            <a:endParaRPr/>
           </a:p>
         </p:txBody>
       </p:sp>
@@ -9471,6 +9682,7 @@
           <a:lstStyle/>
           <a:p>
             <a:pPr algn="ctr"/>
+            <a:endParaRPr/>
           </a:p>
         </p:txBody>
       </p:sp>
@@ -9585,7 +9797,7 @@
 </file>
 
 <file path=ppt/slides/slide6.xml><?xml version="1.0" encoding="utf-8"?>
-<p:sld xmlns:a="http://schemas.openxmlformats.org/drawingml/2006/main" xmlns:p="http://schemas.openxmlformats.org/presentationml/2006/main" xmlns:r="http://schemas.openxmlformats.org/officeDocument/2006/relationships">
+<p:sld xmlns:a="http://schemas.openxmlformats.org/drawingml/2006/main" xmlns:r="http://schemas.openxmlformats.org/officeDocument/2006/relationships" xmlns:p="http://schemas.openxmlformats.org/presentationml/2006/main">
   <p:cSld>
     <p:bg>
       <p:bgPr>
@@ -9601,7 +9813,14 @@
         <p:cNvGrpSpPr/>
         <p:nvPr/>
       </p:nvGrpSpPr>
-      <p:grpSpPr/>
+      <p:grpSpPr>
+        <a:xfrm>
+          <a:off x="0" y="0"/>
+          <a:ext cx="0" cy="0"/>
+          <a:chOff x="0" y="0"/>
+          <a:chExt cx="0" cy="0"/>
+        </a:xfrm>
+      </p:grpSpPr>
       <p:sp>
         <p:nvSpPr>
           <p:cNvPr id="2" name="Rectangle 1"/>
@@ -9642,6 +9861,7 @@
           <a:lstStyle/>
           <a:p>
             <a:pPr algn="ctr"/>
+            <a:endParaRPr/>
           </a:p>
         </p:txBody>
       </p:sp>
@@ -9685,6 +9905,7 @@
           <a:lstStyle/>
           <a:p>
             <a:pPr algn="ctr"/>
+            <a:endParaRPr/>
           </a:p>
         </p:txBody>
       </p:sp>
@@ -9846,6 +10067,7 @@
           <a:lstStyle/>
           <a:p>
             <a:pPr algn="ctr"/>
+            <a:endParaRPr/>
           </a:p>
         </p:txBody>
       </p:sp>
@@ -9925,6 +10147,7 @@
           <a:lstStyle/>
           <a:p>
             <a:pPr algn="ctr"/>
+            <a:endParaRPr/>
           </a:p>
         </p:txBody>
       </p:sp>
@@ -10004,6 +10227,7 @@
           <a:lstStyle/>
           <a:p>
             <a:pPr algn="ctr"/>
+            <a:endParaRPr/>
           </a:p>
         </p:txBody>
       </p:sp>
@@ -10083,6 +10307,7 @@
           <a:lstStyle/>
           <a:p>
             <a:pPr algn="ctr"/>
+            <a:endParaRPr/>
           </a:p>
         </p:txBody>
       </p:sp>
@@ -10162,6 +10387,7 @@
           <a:lstStyle/>
           <a:p>
             <a:pPr algn="ctr"/>
+            <a:endParaRPr/>
           </a:p>
         </p:txBody>
       </p:sp>
@@ -10241,6 +10467,7 @@
           <a:lstStyle/>
           <a:p>
             <a:pPr algn="ctr"/>
+            <a:endParaRPr/>
           </a:p>
         </p:txBody>
       </p:sp>
@@ -10320,6 +10547,7 @@
           <a:lstStyle/>
           <a:p>
             <a:pPr algn="ctr"/>
+            <a:endParaRPr/>
           </a:p>
         </p:txBody>
       </p:sp>
@@ -10399,6 +10627,7 @@
           <a:lstStyle/>
           <a:p>
             <a:pPr algn="ctr"/>
+            <a:endParaRPr/>
           </a:p>
         </p:txBody>
       </p:sp>
@@ -10478,6 +10707,7 @@
           <a:lstStyle/>
           <a:p>
             <a:pPr algn="ctr"/>
+            <a:endParaRPr/>
           </a:p>
         </p:txBody>
       </p:sp>
@@ -10524,7 +10754,7 @@
 </file>
 
 <file path=ppt/slides/slide7.xml><?xml version="1.0" encoding="utf-8"?>
-<p:sld xmlns:a="http://schemas.openxmlformats.org/drawingml/2006/main" xmlns:p="http://schemas.openxmlformats.org/presentationml/2006/main" xmlns:r="http://schemas.openxmlformats.org/officeDocument/2006/relationships">
+<p:sld xmlns:a="http://schemas.openxmlformats.org/drawingml/2006/main" xmlns:r="http://schemas.openxmlformats.org/officeDocument/2006/relationships" xmlns:p="http://schemas.openxmlformats.org/presentationml/2006/main">
   <p:cSld>
     <p:bg>
       <p:bgPr>
@@ -10540,7 +10770,14 @@
         <p:cNvGrpSpPr/>
         <p:nvPr/>
       </p:nvGrpSpPr>
-      <p:grpSpPr/>
+      <p:grpSpPr>
+        <a:xfrm>
+          <a:off x="0" y="0"/>
+          <a:ext cx="0" cy="0"/>
+          <a:chOff x="0" y="0"/>
+          <a:chExt cx="0" cy="0"/>
+        </a:xfrm>
+      </p:grpSpPr>
       <p:sp>
         <p:nvSpPr>
           <p:cNvPr id="2" name="TextBox 1"/>
@@ -10651,6 +10888,7 @@
           <a:lstStyle/>
           <a:p>
             <a:pPr algn="ctr"/>
+            <a:endParaRPr/>
           </a:p>
         </p:txBody>
       </p:sp>
@@ -10694,6 +10932,7 @@
           <a:lstStyle/>
           <a:p>
             <a:pPr algn="ctr"/>
+            <a:endParaRPr/>
           </a:p>
         </p:txBody>
       </p:sp>
@@ -10844,6 +11083,7 @@
           <a:lstStyle/>
           <a:p>
             <a:pPr algn="ctr"/>
+            <a:endParaRPr/>
           </a:p>
         </p:txBody>
       </p:sp>
@@ -10887,6 +11127,7 @@
           <a:lstStyle/>
           <a:p>
             <a:pPr algn="ctr"/>
+            <a:endParaRPr/>
           </a:p>
         </p:txBody>
       </p:sp>
@@ -11037,6 +11278,7 @@
           <a:lstStyle/>
           <a:p>
             <a:pPr algn="ctr"/>
+            <a:endParaRPr/>
           </a:p>
         </p:txBody>
       </p:sp>
@@ -11080,6 +11322,7 @@
           <a:lstStyle/>
           <a:p>
             <a:pPr algn="ctr"/>
+            <a:endParaRPr/>
           </a:p>
         </p:txBody>
       </p:sp>
@@ -11230,6 +11473,7 @@
           <a:lstStyle/>
           <a:p>
             <a:pPr algn="ctr"/>
+            <a:endParaRPr/>
           </a:p>
         </p:txBody>
       </p:sp>
@@ -11273,6 +11517,7 @@
           <a:lstStyle/>
           <a:p>
             <a:pPr algn="ctr"/>
+            <a:endParaRPr/>
           </a:p>
         </p:txBody>
       </p:sp>
@@ -11423,6 +11668,7 @@
           <a:lstStyle/>
           <a:p>
             <a:pPr algn="ctr"/>
+            <a:endParaRPr/>
           </a:p>
         </p:txBody>
       </p:sp>
@@ -11466,6 +11712,7 @@
           <a:lstStyle/>
           <a:p>
             <a:pPr algn="ctr"/>
+            <a:endParaRPr/>
           </a:p>
         </p:txBody>
       </p:sp>
@@ -11616,6 +11863,7 @@
           <a:lstStyle/>
           <a:p>
             <a:pPr algn="ctr"/>
+            <a:endParaRPr/>
           </a:p>
         </p:txBody>
       </p:sp>
@@ -11659,6 +11907,7 @@
           <a:lstStyle/>
           <a:p>
             <a:pPr algn="ctr"/>
+            <a:endParaRPr/>
           </a:p>
         </p:txBody>
       </p:sp>
@@ -11776,7 +12025,7 @@
 </file>
 
 <file path=ppt/slides/slide8.xml><?xml version="1.0" encoding="utf-8"?>
-<p:sld xmlns:a="http://schemas.openxmlformats.org/drawingml/2006/main" xmlns:p="http://schemas.openxmlformats.org/presentationml/2006/main" xmlns:r="http://schemas.openxmlformats.org/officeDocument/2006/relationships">
+<p:sld xmlns:a="http://schemas.openxmlformats.org/drawingml/2006/main" xmlns:r="http://schemas.openxmlformats.org/officeDocument/2006/relationships" xmlns:p="http://schemas.openxmlformats.org/presentationml/2006/main">
   <p:cSld>
     <p:bg>
       <p:bgPr>
@@ -11792,7 +12041,14 @@
         <p:cNvGrpSpPr/>
         <p:nvPr/>
       </p:nvGrpSpPr>
-      <p:grpSpPr/>
+      <p:grpSpPr>
+        <a:xfrm>
+          <a:off x="0" y="0"/>
+          <a:ext cx="0" cy="0"/>
+          <a:chOff x="0" y="0"/>
+          <a:chExt cx="0" cy="0"/>
+        </a:xfrm>
+      </p:grpSpPr>
       <p:sp>
         <p:nvSpPr>
           <p:cNvPr id="2" name="Rectangle 1"/>
@@ -11833,6 +12089,7 @@
           <a:lstStyle/>
           <a:p>
             <a:pPr algn="ctr"/>
+            <a:endParaRPr/>
           </a:p>
         </p:txBody>
       </p:sp>
@@ -11876,6 +12133,7 @@
           <a:lstStyle/>
           <a:p>
             <a:pPr algn="ctr"/>
+            <a:endParaRPr/>
           </a:p>
         </p:txBody>
       </p:sp>
@@ -12105,6 +12363,7 @@
           <a:lstStyle/>
           <a:p>
             <a:pPr algn="ctr"/>
+            <a:endParaRPr/>
           </a:p>
         </p:txBody>
       </p:sp>
@@ -12184,6 +12443,7 @@
           <a:lstStyle/>
           <a:p>
             <a:pPr algn="ctr"/>
+            <a:endParaRPr/>
           </a:p>
         </p:txBody>
       </p:sp>
@@ -12263,6 +12523,7 @@
           <a:lstStyle/>
           <a:p>
             <a:pPr algn="ctr"/>
+            <a:endParaRPr/>
           </a:p>
         </p:txBody>
       </p:sp>
@@ -12342,6 +12603,7 @@
           <a:lstStyle/>
           <a:p>
             <a:pPr algn="ctr"/>
+            <a:endParaRPr/>
           </a:p>
         </p:txBody>
       </p:sp>
@@ -12421,6 +12683,7 @@
           <a:lstStyle/>
           <a:p>
             <a:pPr algn="ctr"/>
+            <a:endParaRPr/>
           </a:p>
         </p:txBody>
       </p:sp>
@@ -12500,6 +12763,7 @@
           <a:lstStyle/>
           <a:p>
             <a:pPr algn="ctr"/>
+            <a:endParaRPr/>
           </a:p>
         </p:txBody>
       </p:sp>
@@ -12579,6 +12843,7 @@
           <a:lstStyle/>
           <a:p>
             <a:pPr algn="ctr"/>
+            <a:endParaRPr/>
           </a:p>
         </p:txBody>
       </p:sp>
@@ -12625,7 +12890,7 @@
 </file>
 
 <file path=ppt/slides/slide9.xml><?xml version="1.0" encoding="utf-8"?>
-<p:sld xmlns:a="http://schemas.openxmlformats.org/drawingml/2006/main" xmlns:p="http://schemas.openxmlformats.org/presentationml/2006/main" xmlns:r="http://schemas.openxmlformats.org/officeDocument/2006/relationships">
+<p:sld xmlns:a="http://schemas.openxmlformats.org/drawingml/2006/main" xmlns:r="http://schemas.openxmlformats.org/officeDocument/2006/relationships" xmlns:p="http://schemas.openxmlformats.org/presentationml/2006/main">
   <p:cSld>
     <p:bg>
       <p:bgPr>
@@ -12641,7 +12906,14 @@
         <p:cNvGrpSpPr/>
         <p:nvPr/>
       </p:nvGrpSpPr>
-      <p:grpSpPr/>
+      <p:grpSpPr>
+        <a:xfrm>
+          <a:off x="0" y="0"/>
+          <a:ext cx="0" cy="0"/>
+          <a:chOff x="0" y="0"/>
+          <a:chExt cx="0" cy="0"/>
+        </a:xfrm>
+      </p:grpSpPr>
       <p:sp>
         <p:nvSpPr>
           <p:cNvPr id="2" name="TextBox 1"/>
@@ -12752,6 +13024,7 @@
           <a:lstStyle/>
           <a:p>
             <a:pPr algn="ctr"/>
+            <a:endParaRPr/>
           </a:p>
         </p:txBody>
       </p:sp>
@@ -12795,6 +13068,7 @@
           <a:lstStyle/>
           <a:p>
             <a:pPr algn="ctr"/>
+            <a:endParaRPr/>
           </a:p>
         </p:txBody>
       </p:sp>
@@ -12957,6 +13231,7 @@
           <a:lstStyle/>
           <a:p>
             <a:pPr algn="ctr"/>
+            <a:endParaRPr/>
           </a:p>
         </p:txBody>
       </p:sp>
@@ -13000,6 +13275,7 @@
           <a:lstStyle/>
           <a:p>
             <a:pPr algn="ctr"/>
+            <a:endParaRPr/>
           </a:p>
         </p:txBody>
       </p:sp>
@@ -13162,6 +13438,7 @@
           <a:lstStyle/>
           <a:p>
             <a:pPr algn="ctr"/>
+            <a:endParaRPr/>
           </a:p>
         </p:txBody>
       </p:sp>
@@ -13205,6 +13482,7 @@
           <a:lstStyle/>
           <a:p>
             <a:pPr algn="ctr"/>
+            <a:endParaRPr/>
           </a:p>
         </p:txBody>
       </p:sp>
@@ -13367,6 +13645,7 @@
           <a:lstStyle/>
           <a:p>
             <a:pPr algn="ctr"/>
+            <a:endParaRPr/>
           </a:p>
         </p:txBody>
       </p:sp>
@@ -13410,6 +13689,7 @@
           <a:lstStyle/>
           <a:p>
             <a:pPr algn="ctr"/>
+            <a:endParaRPr/>
           </a:p>
         </p:txBody>
       </p:sp>

</xml_diff>